<commit_message>
Fold Cloud-PASS M14 exam SAY
Co-authored-by: shaseaver25 <shannon@tailoredu.org>
</commit_message>
<xml_diff>
--- a/teaching-pack/18-M14-exam-1-overweight-permit/M14-exam-launch.pptx
+++ b/teaching-pack/18-M14-exam-1-overweight-permit/M14-exam-launch.pptx
@@ -506,18 +506,18 @@
           <a:lstStyle/>
           <a:p>
             <a:r>
-              <a:t>M14 SAY HOLD — PLACEHOLDER ONLY — NOT CLOUD-PASS.</a:t>
-            </a:r>
-          </a:p>
-          <a:p>
-            <a:r>
-              <a:t>Do not deliver this text as canon. Replace only from the attached Cloud-PASS file in a follow-up.</a:t>
+              <a:t>M14 CANON SAY — Cloud PASS.</a:t>
+            </a:r>
+          </a:p>
+          <a:p>
+            <a:r>
+              <a:t>Clock resolution: setup before the timed block; 75 silent-writing minutes; collect after time. This follows the course and simulation plan and gives 5 more silent minutes than the PASS file's soft 'Exam block 70' label.</a:t>
             </a:r>
           </a:p>
           <a:p/>
           <a:p>
             <a:r>
-              <a:t>RUN-OF-DAY HOOK: [OPENING / identity check placeholder. State the common-file and 75-minute conditions without adding story detail.]</a:t>
+              <a:t>SETUP — SAY: “Exam 1 — overweight permit. Same file for everyone. Diane Halvorsen, PE is unreachable. FOREMAN’s rec is in the packet (orange). Phones away. 75 minutes.” Complete the access check before starting the timed block.</a:t>
             </a:r>
           </a:p>
         </p:txBody>
@@ -587,18 +587,18 @@
           <a:lstStyle/>
           <a:p>
             <a:r>
-              <a:t>M14 SAY HOLD — PLACEHOLDER ONLY — NOT CLOUD-PASS.</a:t>
-            </a:r>
-          </a:p>
-          <a:p>
-            <a:r>
-              <a:t>Do not deliver this text as canon. Replace only from the attached Cloud-PASS file in a follow-up.</a:t>
+              <a:t>M14 CANON SAY — Cloud PASS.</a:t>
+            </a:r>
+          </a:p>
+          <a:p>
+            <a:r>
+              <a:t>Clock resolution: setup before the timed block; 75 silent-writing minutes; collect after time. This follows the course and simulation plan and gives 5 more silent minutes than the PASS file's soft 'Exam block 70' label.</a:t>
             </a:r>
           </a:p>
           <a:p/>
           <a:p>
             <a:r>
-              <a:t>RUN-OF-DAY HOOK: [MATERIALS / integrity placeholder. Confirm allowed files and how students submit work.]</a:t>
+              <a:t>SETUP — Confirm the exam file, FOREMAN recommendation and chart, booklet, and reference sheet. Clarify logistics only—not content. No Wes co-solve and no live Diane.</a:t>
             </a:r>
           </a:p>
         </p:txBody>
@@ -668,18 +668,18 @@
           <a:lstStyle/>
           <a:p>
             <a:r>
-              <a:t>M14 SAY HOLD — PLACEHOLDER ONLY — NOT CLOUD-PASS.</a:t>
-            </a:r>
-          </a:p>
-          <a:p>
-            <a:r>
-              <a:t>Do not deliver this text as canon. Replace only from the attached Cloud-PASS file in a follow-up.</a:t>
+              <a:t>M14 CANON SAY — Cloud PASS.</a:t>
+            </a:r>
+          </a:p>
+          <a:p>
+            <a:r>
+              <a:t>Clock resolution: setup before the timed block; 75 silent-writing minutes; collect after time. This follows the course and simulation plan and gives 5 more silent minutes than the PASS file's soft 'Exam block 70' label.</a:t>
             </a:r>
           </a:p>
           <a:p/>
           <a:p>
             <a:r>
-              <a:t>RUN-OF-DAY HOOK: [SCENARIO boundary placeholder. Name Diane Halvorsen, PE as unreachable only if the Cloud-PASS file does so.]</a:t>
+              <a:t>EXAM CALL — SAY: “Kinnick County Public Works needs a decision today on an overweight permit for a night crossing at the Otter Bend Lift Bridge. FOREMAN recommends approval and says the crossing is fine. You are the human review checkpoint.”</a:t>
             </a:r>
           </a:p>
         </p:txBody>
@@ -749,18 +749,18 @@
           <a:lstStyle/>
           <a:p>
             <a:r>
-              <a:t>M14 SAY HOLD — PLACEHOLDER ONLY — NOT CLOUD-PASS.</a:t>
-            </a:r>
-          </a:p>
-          <a:p>
-            <a:r>
-              <a:t>Do not deliver this text as canon. Replace only from the attached Cloud-PASS file in a follow-up.</a:t>
+              <a:t>M14 CANON SAY — Cloud PASS.</a:t>
+            </a:r>
+          </a:p>
+          <a:p>
+            <a:r>
+              <a:t>Clock resolution: setup before the timed block; 75 silent-writing minutes; collect after time. This follows the course and simulation plan and gives 5 more silent minutes than the PASS file's soft 'Exam block 70' label.</a:t>
             </a:r>
           </a:p>
           <a:p/>
           <a:p>
             <a:r>
-              <a:t>RUN-OF-DAY HOOK: [TIME checks placeholder. Insert locally approved time announcements; do not coach task content.]</a:t>
+              <a:t>SILENT WORK — 75 timed minutes. Make time calls at about 35 minutes remaining and 10 minutes remaining. Clarify logistics only; do not identify a failed claim, chart flaw, or preferred decision branch.</a:t>
             </a:r>
           </a:p>
         </p:txBody>
@@ -830,18 +830,18 @@
           <a:lstStyle/>
           <a:p>
             <a:r>
-              <a:t>M14 SAY HOLD — PLACEHOLDER ONLY — NOT CLOUD-PASS.</a:t>
-            </a:r>
-          </a:p>
-          <a:p>
-            <a:r>
-              <a:t>Do not deliver this text as canon. Replace only from the attached Cloud-PASS file in a follow-up.</a:t>
+              <a:t>M14 CANON SAY — Cloud PASS.</a:t>
+            </a:r>
+          </a:p>
+          <a:p>
+            <a:r>
+              <a:t>Clock resolution: setup before the timed block; 75 silent-writing minutes; collect after time. This follows the course and simulation plan and gives 5 more silent minutes than the PASS file's soft 'Exam block 70' label.</a:t>
             </a:r>
           </a:p>
           <a:p/>
           <a:p>
             <a:r>
-              <a:t>RUN-OF-DAY HOOK: [COLLECTION placeholder. State stop-work, file naming, and collection procedure.]</a:t>
+              <a:t>CLOSE — SAY: “Pens down.” Collect exam-file responses and Note version 2. Do not run a right-answer debrief or open the reveal on exam day.</a:t>
             </a:r>
           </a:p>
         </p:txBody>

</xml_diff>

<commit_message>
Revert "Fold Cloud-PASS M14 exam SAY"
This reverts commit 5710d69eee49c5d1a82d40e4050057d216c1c2ac.
</commit_message>
<xml_diff>
--- a/teaching-pack/18-M14-exam-1-overweight-permit/M14-exam-launch.pptx
+++ b/teaching-pack/18-M14-exam-1-overweight-permit/M14-exam-launch.pptx
@@ -506,18 +506,18 @@
           <a:lstStyle/>
           <a:p>
             <a:r>
-              <a:t>M14 CANON SAY — Cloud PASS.</a:t>
-            </a:r>
-          </a:p>
-          <a:p>
-            <a:r>
-              <a:t>Clock resolution: setup before the timed block; 75 silent-writing minutes; collect after time. This follows the course and simulation plan and gives 5 more silent minutes than the PASS file's soft 'Exam block 70' label.</a:t>
+              <a:t>M14 SAY HOLD — PLACEHOLDER ONLY — NOT CLOUD-PASS.</a:t>
+            </a:r>
+          </a:p>
+          <a:p>
+            <a:r>
+              <a:t>Do not deliver this text as canon. Replace only from the attached Cloud-PASS file in a follow-up.</a:t>
             </a:r>
           </a:p>
           <a:p/>
           <a:p>
             <a:r>
-              <a:t>SETUP — SAY: “Exam 1 — overweight permit. Same file for everyone. Diane Halvorsen, PE is unreachable. FOREMAN’s rec is in the packet (orange). Phones away. 75 minutes.” Complete the access check before starting the timed block.</a:t>
+              <a:t>RUN-OF-DAY HOOK: [OPENING / identity check placeholder. State the common-file and 75-minute conditions without adding story detail.]</a:t>
             </a:r>
           </a:p>
         </p:txBody>
@@ -587,18 +587,18 @@
           <a:lstStyle/>
           <a:p>
             <a:r>
-              <a:t>M14 CANON SAY — Cloud PASS.</a:t>
-            </a:r>
-          </a:p>
-          <a:p>
-            <a:r>
-              <a:t>Clock resolution: setup before the timed block; 75 silent-writing minutes; collect after time. This follows the course and simulation plan and gives 5 more silent minutes than the PASS file's soft 'Exam block 70' label.</a:t>
+              <a:t>M14 SAY HOLD — PLACEHOLDER ONLY — NOT CLOUD-PASS.</a:t>
+            </a:r>
+          </a:p>
+          <a:p>
+            <a:r>
+              <a:t>Do not deliver this text as canon. Replace only from the attached Cloud-PASS file in a follow-up.</a:t>
             </a:r>
           </a:p>
           <a:p/>
           <a:p>
             <a:r>
-              <a:t>SETUP — Confirm the exam file, FOREMAN recommendation and chart, booklet, and reference sheet. Clarify logistics only—not content. No Wes co-solve and no live Diane.</a:t>
+              <a:t>RUN-OF-DAY HOOK: [MATERIALS / integrity placeholder. Confirm allowed files and how students submit work.]</a:t>
             </a:r>
           </a:p>
         </p:txBody>
@@ -668,18 +668,18 @@
           <a:lstStyle/>
           <a:p>
             <a:r>
-              <a:t>M14 CANON SAY — Cloud PASS.</a:t>
-            </a:r>
-          </a:p>
-          <a:p>
-            <a:r>
-              <a:t>Clock resolution: setup before the timed block; 75 silent-writing minutes; collect after time. This follows the course and simulation plan and gives 5 more silent minutes than the PASS file's soft 'Exam block 70' label.</a:t>
+              <a:t>M14 SAY HOLD — PLACEHOLDER ONLY — NOT CLOUD-PASS.</a:t>
+            </a:r>
+          </a:p>
+          <a:p>
+            <a:r>
+              <a:t>Do not deliver this text as canon. Replace only from the attached Cloud-PASS file in a follow-up.</a:t>
             </a:r>
           </a:p>
           <a:p/>
           <a:p>
             <a:r>
-              <a:t>EXAM CALL — SAY: “Kinnick County Public Works needs a decision today on an overweight permit for a night crossing at the Otter Bend Lift Bridge. FOREMAN recommends approval and says the crossing is fine. You are the human review checkpoint.”</a:t>
+              <a:t>RUN-OF-DAY HOOK: [SCENARIO boundary placeholder. Name Diane Halvorsen, PE as unreachable only if the Cloud-PASS file does so.]</a:t>
             </a:r>
           </a:p>
         </p:txBody>
@@ -749,18 +749,18 @@
           <a:lstStyle/>
           <a:p>
             <a:r>
-              <a:t>M14 CANON SAY — Cloud PASS.</a:t>
-            </a:r>
-          </a:p>
-          <a:p>
-            <a:r>
-              <a:t>Clock resolution: setup before the timed block; 75 silent-writing minutes; collect after time. This follows the course and simulation plan and gives 5 more silent minutes than the PASS file's soft 'Exam block 70' label.</a:t>
+              <a:t>M14 SAY HOLD — PLACEHOLDER ONLY — NOT CLOUD-PASS.</a:t>
+            </a:r>
+          </a:p>
+          <a:p>
+            <a:r>
+              <a:t>Do not deliver this text as canon. Replace only from the attached Cloud-PASS file in a follow-up.</a:t>
             </a:r>
           </a:p>
           <a:p/>
           <a:p>
             <a:r>
-              <a:t>SILENT WORK — 75 timed minutes. Make time calls at about 35 minutes remaining and 10 minutes remaining. Clarify logistics only; do not identify a failed claim, chart flaw, or preferred decision branch.</a:t>
+              <a:t>RUN-OF-DAY HOOK: [TIME checks placeholder. Insert locally approved time announcements; do not coach task content.]</a:t>
             </a:r>
           </a:p>
         </p:txBody>
@@ -830,18 +830,18 @@
           <a:lstStyle/>
           <a:p>
             <a:r>
-              <a:t>M14 CANON SAY — Cloud PASS.</a:t>
-            </a:r>
-          </a:p>
-          <a:p>
-            <a:r>
-              <a:t>Clock resolution: setup before the timed block; 75 silent-writing minutes; collect after time. This follows the course and simulation plan and gives 5 more silent minutes than the PASS file's soft 'Exam block 70' label.</a:t>
+              <a:t>M14 SAY HOLD — PLACEHOLDER ONLY — NOT CLOUD-PASS.</a:t>
+            </a:r>
+          </a:p>
+          <a:p>
+            <a:r>
+              <a:t>Do not deliver this text as canon. Replace only from the attached Cloud-PASS file in a follow-up.</a:t>
             </a:r>
           </a:p>
           <a:p/>
           <a:p>
             <a:r>
-              <a:t>CLOSE — SAY: “Pens down.” Collect exam-file responses and Note version 2. Do not run a right-answer debrief or open the reveal on exam day.</a:t>
+              <a:t>RUN-OF-DAY HOOK: [COLLECTION placeholder. State stop-work, file naming, and collection procedure.]</a:t>
             </a:r>
           </a:p>
         </p:txBody>

</xml_diff>

<commit_message>
Reapply "Fold Cloud-PASS M14 exam SAY"
This reverts commit d2434907d0376321689dd9e707e758c2950ce26c.
</commit_message>
<xml_diff>
--- a/teaching-pack/18-M14-exam-1-overweight-permit/M14-exam-launch.pptx
+++ b/teaching-pack/18-M14-exam-1-overweight-permit/M14-exam-launch.pptx
@@ -506,18 +506,18 @@
           <a:lstStyle/>
           <a:p>
             <a:r>
-              <a:t>M14 SAY HOLD — PLACEHOLDER ONLY — NOT CLOUD-PASS.</a:t>
-            </a:r>
-          </a:p>
-          <a:p>
-            <a:r>
-              <a:t>Do not deliver this text as canon. Replace only from the attached Cloud-PASS file in a follow-up.</a:t>
+              <a:t>M14 CANON SAY — Cloud PASS.</a:t>
+            </a:r>
+          </a:p>
+          <a:p>
+            <a:r>
+              <a:t>Clock resolution: setup before the timed block; 75 silent-writing minutes; collect after time. This follows the course and simulation plan and gives 5 more silent minutes than the PASS file's soft 'Exam block 70' label.</a:t>
             </a:r>
           </a:p>
           <a:p/>
           <a:p>
             <a:r>
-              <a:t>RUN-OF-DAY HOOK: [OPENING / identity check placeholder. State the common-file and 75-minute conditions without adding story detail.]</a:t>
+              <a:t>SETUP — SAY: “Exam 1 — overweight permit. Same file for everyone. Diane Halvorsen, PE is unreachable. FOREMAN’s rec is in the packet (orange). Phones away. 75 minutes.” Complete the access check before starting the timed block.</a:t>
             </a:r>
           </a:p>
         </p:txBody>
@@ -587,18 +587,18 @@
           <a:lstStyle/>
           <a:p>
             <a:r>
-              <a:t>M14 SAY HOLD — PLACEHOLDER ONLY — NOT CLOUD-PASS.</a:t>
-            </a:r>
-          </a:p>
-          <a:p>
-            <a:r>
-              <a:t>Do not deliver this text as canon. Replace only from the attached Cloud-PASS file in a follow-up.</a:t>
+              <a:t>M14 CANON SAY — Cloud PASS.</a:t>
+            </a:r>
+          </a:p>
+          <a:p>
+            <a:r>
+              <a:t>Clock resolution: setup before the timed block; 75 silent-writing minutes; collect after time. This follows the course and simulation plan and gives 5 more silent minutes than the PASS file's soft 'Exam block 70' label.</a:t>
             </a:r>
           </a:p>
           <a:p/>
           <a:p>
             <a:r>
-              <a:t>RUN-OF-DAY HOOK: [MATERIALS / integrity placeholder. Confirm allowed files and how students submit work.]</a:t>
+              <a:t>SETUP — Confirm the exam file, FOREMAN recommendation and chart, booklet, and reference sheet. Clarify logistics only—not content. No Wes co-solve and no live Diane.</a:t>
             </a:r>
           </a:p>
         </p:txBody>
@@ -668,18 +668,18 @@
           <a:lstStyle/>
           <a:p>
             <a:r>
-              <a:t>M14 SAY HOLD — PLACEHOLDER ONLY — NOT CLOUD-PASS.</a:t>
-            </a:r>
-          </a:p>
-          <a:p>
-            <a:r>
-              <a:t>Do not deliver this text as canon. Replace only from the attached Cloud-PASS file in a follow-up.</a:t>
+              <a:t>M14 CANON SAY — Cloud PASS.</a:t>
+            </a:r>
+          </a:p>
+          <a:p>
+            <a:r>
+              <a:t>Clock resolution: setup before the timed block; 75 silent-writing minutes; collect after time. This follows the course and simulation plan and gives 5 more silent minutes than the PASS file's soft 'Exam block 70' label.</a:t>
             </a:r>
           </a:p>
           <a:p/>
           <a:p>
             <a:r>
-              <a:t>RUN-OF-DAY HOOK: [SCENARIO boundary placeholder. Name Diane Halvorsen, PE as unreachable only if the Cloud-PASS file does so.]</a:t>
+              <a:t>EXAM CALL — SAY: “Kinnick County Public Works needs a decision today on an overweight permit for a night crossing at the Otter Bend Lift Bridge. FOREMAN recommends approval and says the crossing is fine. You are the human review checkpoint.”</a:t>
             </a:r>
           </a:p>
         </p:txBody>
@@ -749,18 +749,18 @@
           <a:lstStyle/>
           <a:p>
             <a:r>
-              <a:t>M14 SAY HOLD — PLACEHOLDER ONLY — NOT CLOUD-PASS.</a:t>
-            </a:r>
-          </a:p>
-          <a:p>
-            <a:r>
-              <a:t>Do not deliver this text as canon. Replace only from the attached Cloud-PASS file in a follow-up.</a:t>
+              <a:t>M14 CANON SAY — Cloud PASS.</a:t>
+            </a:r>
+          </a:p>
+          <a:p>
+            <a:r>
+              <a:t>Clock resolution: setup before the timed block; 75 silent-writing minutes; collect after time. This follows the course and simulation plan and gives 5 more silent minutes than the PASS file's soft 'Exam block 70' label.</a:t>
             </a:r>
           </a:p>
           <a:p/>
           <a:p>
             <a:r>
-              <a:t>RUN-OF-DAY HOOK: [TIME checks placeholder. Insert locally approved time announcements; do not coach task content.]</a:t>
+              <a:t>SILENT WORK — 75 timed minutes. Make time calls at about 35 minutes remaining and 10 minutes remaining. Clarify logistics only; do not identify a failed claim, chart flaw, or preferred decision branch.</a:t>
             </a:r>
           </a:p>
         </p:txBody>
@@ -830,18 +830,18 @@
           <a:lstStyle/>
           <a:p>
             <a:r>
-              <a:t>M14 SAY HOLD — PLACEHOLDER ONLY — NOT CLOUD-PASS.</a:t>
-            </a:r>
-          </a:p>
-          <a:p>
-            <a:r>
-              <a:t>Do not deliver this text as canon. Replace only from the attached Cloud-PASS file in a follow-up.</a:t>
+              <a:t>M14 CANON SAY — Cloud PASS.</a:t>
+            </a:r>
+          </a:p>
+          <a:p>
+            <a:r>
+              <a:t>Clock resolution: setup before the timed block; 75 silent-writing minutes; collect after time. This follows the course and simulation plan and gives 5 more silent minutes than the PASS file's soft 'Exam block 70' label.</a:t>
             </a:r>
           </a:p>
           <a:p/>
           <a:p>
             <a:r>
-              <a:t>RUN-OF-DAY HOOK: [COLLECTION placeholder. State stop-work, file naming, and collection procedure.]</a:t>
+              <a:t>CLOSE — SAY: “Pens down.” Collect exam-file responses and Note version 2. Do not run a right-answer debrief or open the reveal on exam day.</a:t>
             </a:r>
           </a:p>
         </p:txBody>

</xml_diff>

<commit_message>
Lock M14 exam to 75 writing minutes
Co-authored-by: shaseaver25 <shannon@tailoredu.org>
</commit_message>
<xml_diff>
--- a/teaching-pack/18-M14-exam-1-overweight-permit/M14-exam-launch.pptx
+++ b/teaching-pack/18-M14-exam-1-overweight-permit/M14-exam-launch.pptx
@@ -511,7 +511,7 @@
           </a:p>
           <a:p>
             <a:r>
-              <a:t>Clock resolution: setup before the timed block; 75 silent-writing minutes; collect after time. This follows the course and simulation plan and gives 5 more silent minutes than the PASS file's soft 'Exam block 70' label.</a:t>
+              <a:t>Clock lock: 75 writing minutes per the syllabus. Setup and collection are proctor overhead and are not subtracted from student writing time.</a:t>
             </a:r>
           </a:p>
           <a:p/>
@@ -592,7 +592,7 @@
           </a:p>
           <a:p>
             <a:r>
-              <a:t>Clock resolution: setup before the timed block; 75 silent-writing minutes; collect after time. This follows the course and simulation plan and gives 5 more silent minutes than the PASS file's soft 'Exam block 70' label.</a:t>
+              <a:t>Clock lock: 75 writing minutes per the syllabus. Setup and collection are proctor overhead and are not subtracted from student writing time.</a:t>
             </a:r>
           </a:p>
           <a:p/>
@@ -673,7 +673,7 @@
           </a:p>
           <a:p>
             <a:r>
-              <a:t>Clock resolution: setup before the timed block; 75 silent-writing minutes; collect after time. This follows the course and simulation plan and gives 5 more silent minutes than the PASS file's soft 'Exam block 70' label.</a:t>
+              <a:t>Clock lock: 75 writing minutes per the syllabus. Setup and collection are proctor overhead and are not subtracted from student writing time.</a:t>
             </a:r>
           </a:p>
           <a:p/>
@@ -754,7 +754,7 @@
           </a:p>
           <a:p>
             <a:r>
-              <a:t>Clock resolution: setup before the timed block; 75 silent-writing minutes; collect after time. This follows the course and simulation plan and gives 5 more silent minutes than the PASS file's soft 'Exam block 70' label.</a:t>
+              <a:t>Clock lock: 75 writing minutes per the syllabus. Setup and collection are proctor overhead and are not subtracted from student writing time.</a:t>
             </a:r>
           </a:p>
           <a:p/>
@@ -835,7 +835,7 @@
           </a:p>
           <a:p>
             <a:r>
-              <a:t>Clock resolution: setup before the timed block; 75 silent-writing minutes; collect after time. This follows the course and simulation plan and gives 5 more silent minutes than the PASS file's soft 'Exam block 70' label.</a:t>
+              <a:t>Clock lock: 75 writing minutes per the syllabus. Setup and collection are proctor overhead and are not subtracted from student writing time.</a:t>
             </a:r>
           </a:p>
           <a:p/>

</xml_diff>